<commit_message>
Flags PPTX: add Senegal, Côte d'Ivoire, Algeria, Morocco (120x60mm)
Now 8 flags, each a 120x60mm slide, rendered crisply. Egypt (Eagle of
Saladin) and Mongolia 1940-45 (Soyombo) pending source images — their
detailed emblems can't be hand-drawn accurately and sources are network-
blocked here.

Co-Authored-By: Claude Opus 4.8 <noreply@anthropic.com>
Claude-Session: https://claude.ai/code/session_01TnVy1C21x68ctXsvvdvyLV
</commit_message>
<xml_diff>
--- a/print/C-Garden-Flags-120x60mm.pptx
+++ b/print/C-Garden-Flags-120x60mm.pptx
@@ -9,6 +9,10 @@
     <p:sldId id="257" r:id="rId8"/>
     <p:sldId id="258" r:id="rId9"/>
     <p:sldId id="259" r:id="rId10"/>
+    <p:sldId id="260" r:id="rId11"/>
+    <p:sldId id="261" r:id="rId12"/>
+    <p:sldId id="262" r:id="rId13"/>
+    <p:sldId id="263" r:id="rId14"/>
   </p:sldIdLst>
   <p:sldSz cx="4320000" cy="2160000" type="screen4x3"/>
   <p:notesSz cx="6858000" cy="9144000"/>
@@ -3249,6 +3253,174 @@
 </p:sld>
 </file>
 
+<file path=ppt/slides/slide5.xml><?xml version="1.0" encoding="utf-8"?>
+<p:sld xmlns:a="http://schemas.openxmlformats.org/drawingml/2006/main" xmlns:p="http://schemas.openxmlformats.org/presentationml/2006/main" xmlns:r="http://schemas.openxmlformats.org/officeDocument/2006/relationships">
+  <p:cSld>
+    <p:spTree>
+      <p:nvGrpSpPr>
+        <p:cNvPr id="1" name=""/>
+        <p:cNvGrpSpPr/>
+        <p:nvPr/>
+      </p:nvGrpSpPr>
+      <p:grpSpPr/>
+      <p:pic>
+        <p:nvPicPr>
+          <p:cNvPr id="2" name="Picture 1" descr="flag_senegal.png"/>
+          <p:cNvPicPr>
+            <a:picLocks noChangeAspect="1"/>
+          </p:cNvPicPr>
+          <p:nvPr/>
+        </p:nvPicPr>
+        <p:blipFill>
+          <a:blip r:embed="rId2"/>
+          <a:stretch>
+            <a:fillRect/>
+          </a:stretch>
+        </p:blipFill>
+        <p:spPr>
+          <a:xfrm>
+            <a:off x="0" y="0"/>
+            <a:ext cx="4320000" cy="2160000"/>
+          </a:xfrm>
+          <a:prstGeom prst="rect">
+            <a:avLst/>
+          </a:prstGeom>
+        </p:spPr>
+      </p:pic>
+    </p:spTree>
+  </p:cSld>
+  <p:clrMapOvr>
+    <a:masterClrMapping/>
+  </p:clrMapOvr>
+</p:sld>
+</file>
+
+<file path=ppt/slides/slide6.xml><?xml version="1.0" encoding="utf-8"?>
+<p:sld xmlns:a="http://schemas.openxmlformats.org/drawingml/2006/main" xmlns:p="http://schemas.openxmlformats.org/presentationml/2006/main" xmlns:r="http://schemas.openxmlformats.org/officeDocument/2006/relationships">
+  <p:cSld>
+    <p:spTree>
+      <p:nvGrpSpPr>
+        <p:cNvPr id="1" name=""/>
+        <p:cNvGrpSpPr/>
+        <p:nvPr/>
+      </p:nvGrpSpPr>
+      <p:grpSpPr/>
+      <p:pic>
+        <p:nvPicPr>
+          <p:cNvPr id="2" name="Picture 1" descr="flag_cotedivoire.png"/>
+          <p:cNvPicPr>
+            <a:picLocks noChangeAspect="1"/>
+          </p:cNvPicPr>
+          <p:nvPr/>
+        </p:nvPicPr>
+        <p:blipFill>
+          <a:blip r:embed="rId2"/>
+          <a:stretch>
+            <a:fillRect/>
+          </a:stretch>
+        </p:blipFill>
+        <p:spPr>
+          <a:xfrm>
+            <a:off x="0" y="0"/>
+            <a:ext cx="4320000" cy="2160000"/>
+          </a:xfrm>
+          <a:prstGeom prst="rect">
+            <a:avLst/>
+          </a:prstGeom>
+        </p:spPr>
+      </p:pic>
+    </p:spTree>
+  </p:cSld>
+  <p:clrMapOvr>
+    <a:masterClrMapping/>
+  </p:clrMapOvr>
+</p:sld>
+</file>
+
+<file path=ppt/slides/slide7.xml><?xml version="1.0" encoding="utf-8"?>
+<p:sld xmlns:a="http://schemas.openxmlformats.org/drawingml/2006/main" xmlns:p="http://schemas.openxmlformats.org/presentationml/2006/main" xmlns:r="http://schemas.openxmlformats.org/officeDocument/2006/relationships">
+  <p:cSld>
+    <p:spTree>
+      <p:nvGrpSpPr>
+        <p:cNvPr id="1" name=""/>
+        <p:cNvGrpSpPr/>
+        <p:nvPr/>
+      </p:nvGrpSpPr>
+      <p:grpSpPr/>
+      <p:pic>
+        <p:nvPicPr>
+          <p:cNvPr id="2" name="Picture 1" descr="flag_algeria.png"/>
+          <p:cNvPicPr>
+            <a:picLocks noChangeAspect="1"/>
+          </p:cNvPicPr>
+          <p:nvPr/>
+        </p:nvPicPr>
+        <p:blipFill>
+          <a:blip r:embed="rId2"/>
+          <a:stretch>
+            <a:fillRect/>
+          </a:stretch>
+        </p:blipFill>
+        <p:spPr>
+          <a:xfrm>
+            <a:off x="0" y="0"/>
+            <a:ext cx="4320000" cy="2160000"/>
+          </a:xfrm>
+          <a:prstGeom prst="rect">
+            <a:avLst/>
+          </a:prstGeom>
+        </p:spPr>
+      </p:pic>
+    </p:spTree>
+  </p:cSld>
+  <p:clrMapOvr>
+    <a:masterClrMapping/>
+  </p:clrMapOvr>
+</p:sld>
+</file>
+
+<file path=ppt/slides/slide8.xml><?xml version="1.0" encoding="utf-8"?>
+<p:sld xmlns:a="http://schemas.openxmlformats.org/drawingml/2006/main" xmlns:p="http://schemas.openxmlformats.org/presentationml/2006/main" xmlns:r="http://schemas.openxmlformats.org/officeDocument/2006/relationships">
+  <p:cSld>
+    <p:spTree>
+      <p:nvGrpSpPr>
+        <p:cNvPr id="1" name=""/>
+        <p:cNvGrpSpPr/>
+        <p:nvPr/>
+      </p:nvGrpSpPr>
+      <p:grpSpPr/>
+      <p:pic>
+        <p:nvPicPr>
+          <p:cNvPr id="2" name="Picture 1" descr="flag_morocco.png"/>
+          <p:cNvPicPr>
+            <a:picLocks noChangeAspect="1"/>
+          </p:cNvPicPr>
+          <p:nvPr/>
+        </p:nvPicPr>
+        <p:blipFill>
+          <a:blip r:embed="rId2"/>
+          <a:stretch>
+            <a:fillRect/>
+          </a:stretch>
+        </p:blipFill>
+        <p:spPr>
+          <a:xfrm>
+            <a:off x="0" y="0"/>
+            <a:ext cx="4320000" cy="2160000"/>
+          </a:xfrm>
+          <a:prstGeom prst="rect">
+            <a:avLst/>
+          </a:prstGeom>
+        </p:spPr>
+      </p:pic>
+    </p:spTree>
+  </p:cSld>
+  <p:clrMapOvr>
+    <a:masterClrMapping/>
+  </p:clrMapOvr>
+</p:sld>
+</file>
+
 <file path=ppt/theme/theme1.xml><?xml version="1.0" encoding="utf-8"?>
 <a:theme xmlns:a="http://schemas.openxmlformats.org/drawingml/2006/main" name="Office Theme">
   <a:themeElements>

</xml_diff>

<commit_message>
Flags PPTX: add Colombia and Argentina (now 10 flags, 120x60mm)
Paraguay, Ecuador, Brazil pending (detailed coats of arms can't be hand-drawn
accurately; sources network-blocked).

Co-Authored-By: Claude Opus 4.8 <noreply@anthropic.com>
Claude-Session: https://claude.ai/code/session_01TnVy1C21x68ctXsvvdvyLV
</commit_message>
<xml_diff>
--- a/print/C-Garden-Flags-120x60mm.pptx
+++ b/print/C-Garden-Flags-120x60mm.pptx
@@ -13,6 +13,8 @@
     <p:sldId id="261" r:id="rId12"/>
     <p:sldId id="262" r:id="rId13"/>
     <p:sldId id="263" r:id="rId14"/>
+    <p:sldId id="264" r:id="rId15"/>
+    <p:sldId id="265" r:id="rId16"/>
   </p:sldIdLst>
   <p:sldSz cx="4320000" cy="2160000" type="screen4x3"/>
   <p:notesSz cx="6858000" cy="9144000"/>
@@ -3127,6 +3129,48 @@
 </p:sld>
 </file>
 
+<file path=ppt/slides/slide10.xml><?xml version="1.0" encoding="utf-8"?>
+<p:sld xmlns:a="http://schemas.openxmlformats.org/drawingml/2006/main" xmlns:p="http://schemas.openxmlformats.org/presentationml/2006/main" xmlns:r="http://schemas.openxmlformats.org/officeDocument/2006/relationships">
+  <p:cSld>
+    <p:spTree>
+      <p:nvGrpSpPr>
+        <p:cNvPr id="1" name=""/>
+        <p:cNvGrpSpPr/>
+        <p:nvPr/>
+      </p:nvGrpSpPr>
+      <p:grpSpPr/>
+      <p:pic>
+        <p:nvPicPr>
+          <p:cNvPr id="2" name="Picture 1" descr="flag_argentina.png"/>
+          <p:cNvPicPr>
+            <a:picLocks noChangeAspect="1"/>
+          </p:cNvPicPr>
+          <p:nvPr/>
+        </p:nvPicPr>
+        <p:blipFill>
+          <a:blip r:embed="rId2"/>
+          <a:stretch>
+            <a:fillRect/>
+          </a:stretch>
+        </p:blipFill>
+        <p:spPr>
+          <a:xfrm>
+            <a:off x="0" y="0"/>
+            <a:ext cx="4320000" cy="2160000"/>
+          </a:xfrm>
+          <a:prstGeom prst="rect">
+            <a:avLst/>
+          </a:prstGeom>
+        </p:spPr>
+      </p:pic>
+    </p:spTree>
+  </p:cSld>
+  <p:clrMapOvr>
+    <a:masterClrMapping/>
+  </p:clrMapOvr>
+</p:sld>
+</file>
+
 <file path=ppt/slides/slide2.xml><?xml version="1.0" encoding="utf-8"?>
 <p:sld xmlns:a="http://schemas.openxmlformats.org/drawingml/2006/main" xmlns:p="http://schemas.openxmlformats.org/presentationml/2006/main" xmlns:r="http://schemas.openxmlformats.org/officeDocument/2006/relationships">
   <p:cSld>
@@ -3392,6 +3436,48 @@
       <p:pic>
         <p:nvPicPr>
           <p:cNvPr id="2" name="Picture 1" descr="flag_morocco.png"/>
+          <p:cNvPicPr>
+            <a:picLocks noChangeAspect="1"/>
+          </p:cNvPicPr>
+          <p:nvPr/>
+        </p:nvPicPr>
+        <p:blipFill>
+          <a:blip r:embed="rId2"/>
+          <a:stretch>
+            <a:fillRect/>
+          </a:stretch>
+        </p:blipFill>
+        <p:spPr>
+          <a:xfrm>
+            <a:off x="0" y="0"/>
+            <a:ext cx="4320000" cy="2160000"/>
+          </a:xfrm>
+          <a:prstGeom prst="rect">
+            <a:avLst/>
+          </a:prstGeom>
+        </p:spPr>
+      </p:pic>
+    </p:spTree>
+  </p:cSld>
+  <p:clrMapOvr>
+    <a:masterClrMapping/>
+  </p:clrMapOvr>
+</p:sld>
+</file>
+
+<file path=ppt/slides/slide9.xml><?xml version="1.0" encoding="utf-8"?>
+<p:sld xmlns:a="http://schemas.openxmlformats.org/drawingml/2006/main" xmlns:p="http://schemas.openxmlformats.org/presentationml/2006/main" xmlns:r="http://schemas.openxmlformats.org/officeDocument/2006/relationships">
+  <p:cSld>
+    <p:spTree>
+      <p:nvGrpSpPr>
+        <p:cNvPr id="1" name=""/>
+        <p:cNvGrpSpPr/>
+        <p:nvPr/>
+      </p:nvGrpSpPr>
+      <p:grpSpPr/>
+      <p:pic>
+        <p:nvPicPr>
+          <p:cNvPr id="2" name="Picture 1" descr="flag_colombia.png"/>
           <p:cNvPicPr>
             <a:picLocks noChangeAspect="1"/>
           </p:cNvPicPr>

</xml_diff>